<commit_message>
Add conversation playbook, acquisition model and tracking workbook
- Manual-de-Conversacion.pdf: EN/ES scripts for every funnel stage and objections
- Modelo-de-Captacion-y-Automatizacion.pdf: funnel, personas, channels,
  WhatsApp Business and ManyChat setup, 32-day calendar, Meta ads, KPIs
- Tablero-Captacion-Tutores.xlsx: leads CRM, plan-vs-actual funnel,
  content calendar and WhatsApp quick replies with real links

Co-Authored-By: Claude Opus 5.5 <noreply@anthropic.com>
Claude-Session: https://claude.ai/code/session_015DeE3q7zyiCoMU8NMTtUUa
</commit_message>
<xml_diff>
--- a/referidos/salidas/Free-30min-Session-EN.pptx
+++ b/referidos/salidas/Free-30min-Session-EN.pptx
@@ -117,27 +117,27 @@
   <p:extLst>
     <p:ext uri="{521415D9-36F7-43E2-AB2F-B90AF26B5E84}">
       <p14:sectionLst xmlns:p14="http://schemas.microsoft.com/office/powerpoint/2010/main">
-        <p14:section name="Opening" id="{d37e9bfa-0011-9ce8-98bf-1e48c12a6890}">
+        <p14:section name="Opening" id="{4a5c5e38-d609-ea65-3a98-333bf8f6e0dd}">
           <p14:sldIdLst>
             <p14:sldId id="256"/>
             <p14:sldId id="257"/>
             <p14:sldId id="258"/>
           </p14:sldIdLst>
         </p14:section>
-        <p14:section name="Profile" id="{687c4c9d-042f-7965-f254-ba3eb6936815}">
+        <p14:section name="Profile" id="{26a41391-5781-029c-1891-01389ba6bf66}">
           <p14:sldIdLst>
             <p14:sldId id="259"/>
             <p14:sldId id="260"/>
             <p14:sldId id="261"/>
           </p14:sldIdLst>
         </p14:section>
-        <p14:section name="Pricing and trial lesson" id="{7454853e-ba7a-443d-7727-9bb178769b75}">
+        <p14:section name="Pricing and trial lesson" id="{e08eaa1d-a9c8-11af-18e9-49662433b4db}">
           <p14:sldIdLst>
             <p14:sldId id="262"/>
             <p14:sldId id="263"/>
           </p14:sldIdLst>
         </p14:section>
-        <p14:section name="Closing" id="{63e34637-884a-3569-bb1f-2d029185deb2}">
+        <p14:section name="Closing" id="{f8b5b48f-dbb6-944b-a55e-549e75b0e53d}">
           <p14:sldIdLst>
             <p14:sldId id="264"/>
             <p14:sldId id="265"/>

</xml_diff>